<commit_message>
Corrige el informe del APF2 según las observaciones del docente
Citas APA dentro de los párrafos, notas en tablas y figuras, sin formulación
del problema, objetivo general directo y objetivos específicos con indicador.
Regenera Word y presentaciones, y guarda las observaciones y la memoria 006.

Co-Authored-By: Claude Opus 5.5 <noreply@anthropic.com>
</commit_message>
<xml_diff>
--- a/documentos_teoricos/entregable2/entregable2_presentacion.pptx
+++ b/documentos_teoricos/entregable2/entregable2_presentacion.pptx
@@ -796,7 +796,7 @@
           <a:lstStyle/>
           <a:p>
             <a:r>
-              <a:t>Fabrizzio: Validamos el diseño con matrices de cobertura. Cada uno de los 22 requerimientos funcionales tiene pantalla, caso de uso, clase y tabla; los 19 no funcionales tienen una decisión de diseño verificable. Hicimos una evaluación heurística con las diez heurísticas de Nielsen y un recorrido de seis tareas, y definimos la prueba con tres titulares para la iteración 3. Devuelvo la palabra a Diego.</a:t>
+              <a:t>Fabrizzio: Validamos el diseño con matrices de cobertura. Cada uno de los 22 requerimientos funcionales tiene pantalla, caso de uso, clase y tabla; los 19 no funcionales tienen una decisión de diseño verificable. Hicimos una evaluación heurística con las diez heurísticas de Nielsen y un recorrido de seis tareas, y definimos la prueba con tres titulares para las semanas 11 y 12, en la iteración 4. Devuelvo la palabra a Diego.</a:t>
             </a:r>
           </a:p>
         </p:txBody>
@@ -8262,7 +8262,7 @@
                 </a:solidFill>
                 <a:latin typeface="Calibri"/>
               </a:rPr>
-              <a:t>Metas de usabilidad (I3)</a:t>
+              <a:t>Metas de usabilidad (I4, sem. 11–12)</a:t>
             </a:r>
           </a:p>
         </p:txBody>

</xml_diff>